<commit_message>
Refactor short talk titles and timestamps for clarity and consistency; add new shorts for "Barrel-of-Monkeys Maneuver" and update related content. Adjust timestamps in dynamic scaling scripts to align with new structure. Update README to reflect changes in short talk titles and pairings.
</commit_message>
<xml_diff>
--- a/artifacts/speaking-portfolio-expanded/decks/dynamic-scaling-30min-screen.pptx
+++ b/artifacts/speaking-portfolio-expanded/decks/dynamic-scaling-30min-screen.pptx
@@ -677,99 +677,99 @@
                 <a:ea typeface="Arial"/>
                 <a:cs typeface="Arial"/>
               </a:rPr>
-              <a:t xml:space="preserve">Source slide 12. 22:00 to 25:30</a:t>
-            </a:r>
-            <a:endParaRPr lang="en-US" sz="1200"/>
-          </a:p>
-          <a:p>
-            <a:pPr marL="0" indent="0">
-              <a:lnSpc>
-                <a:spcPts val="1560"/>
-              </a:lnSpc>
-              <a:spcAft>
-                <a:spcPts val="0"/>
-              </a:spcAft>
-              <a:buNone/>
-            </a:pPr>
-            <a:r>
-              <a:rPr lang="en-US" sz="1200" b="0">
-                <a:solidFill>
-                  <a:srgbClr val="202b33"/>
-                </a:solidFill>
-                <a:latin typeface="Arial"/>
-                <a:ea typeface="Arial"/>
-                <a:cs typeface="Arial"/>
-              </a:rPr>
-              <a:t xml:space="preserve"/>
-            </a:r>
-            <a:endParaRPr lang="en-US" sz="1200"/>
-          </a:p>
-          <a:p>
-            <a:pPr marL="0" indent="0">
-              <a:lnSpc>
-                <a:spcPts val="1560"/>
-              </a:lnSpc>
-              <a:spcAft>
-                <a:spcPts val="0"/>
-              </a:spcAft>
-              <a:buNone/>
-            </a:pPr>
-            <a:r>
-              <a:rPr lang="en-US" sz="1200" b="0">
-                <a:solidFill>
-                  <a:srgbClr val="202b33"/>
-                </a:solidFill>
-                <a:latin typeface="Arial"/>
-                <a:ea typeface="Arial"/>
-                <a:cs typeface="Arial"/>
-              </a:rPr>
-              <a:t xml:space="preserve">Same brief, contrasting priorities, separate first drafts</a:t>
-            </a:r>
-            <a:endParaRPr lang="en-US" sz="1200"/>
-          </a:p>
-          <a:p>
-            <a:pPr marL="0" indent="0">
-              <a:lnSpc>
-                <a:spcPts val="1560"/>
-              </a:lnSpc>
-              <a:spcAft>
-                <a:spcPts val="0"/>
-              </a:spcAft>
-              <a:buNone/>
-            </a:pPr>
-            <a:r>
-              <a:rPr lang="en-US" sz="1200" b="0">
-                <a:solidFill>
-                  <a:srgbClr val="202b33"/>
-                </a:solidFill>
-                <a:latin typeface="Arial"/>
-                <a:ea typeface="Arial"/>
-                <a:cs typeface="Arial"/>
-              </a:rPr>
-              <a:t xml:space="preserve"/>
-            </a:r>
-            <a:endParaRPr lang="en-US" sz="1200"/>
-          </a:p>
-          <a:p>
-            <a:pPr marL="0" indent="0">
-              <a:lnSpc>
-                <a:spcPts val="1560"/>
-              </a:lnSpc>
-              <a:spcAft>
-                <a:spcPts val="0"/>
-              </a:spcAft>
-              <a:buNone/>
-            </a:pPr>
-            <a:r>
-              <a:rPr lang="en-US" sz="1200" b="0">
-                <a:solidFill>
-                  <a:srgbClr val="202b33"/>
-                </a:solidFill>
-                <a:latin typeface="Arial"/>
-                <a:ea typeface="Arial"/>
-                <a:cs typeface="Arial"/>
-              </a:rPr>
-              <a:t xml:space="preserve">A judge reads a thousand tokens and writes fifty. Run a council. Measure the disagreement.</a:t>
+              <a:t xml:space="preserve">Source slide 12. 21:30 to 26:00</a:t>
+            </a:r>
+            <a:endParaRPr lang="en-US" sz="1200"/>
+          </a:p>
+          <a:p>
+            <a:pPr marL="0" indent="0">
+              <a:lnSpc>
+                <a:spcPts val="1560"/>
+              </a:lnSpc>
+              <a:spcAft>
+                <a:spcPts val="0"/>
+              </a:spcAft>
+              <a:buNone/>
+            </a:pPr>
+            <a:r>
+              <a:rPr lang="en-US" sz="1200" b="0">
+                <a:solidFill>
+                  <a:srgbClr val="202b33"/>
+                </a:solidFill>
+                <a:latin typeface="Arial"/>
+                <a:ea typeface="Arial"/>
+                <a:cs typeface="Arial"/>
+              </a:rPr>
+              <a:t xml:space="preserve"/>
+            </a:r>
+            <a:endParaRPr lang="en-US" sz="1200"/>
+          </a:p>
+          <a:p>
+            <a:pPr marL="0" indent="0">
+              <a:lnSpc>
+                <a:spcPts val="1560"/>
+              </a:lnSpc>
+              <a:spcAft>
+                <a:spcPts val="0"/>
+              </a:spcAft>
+              <a:buNone/>
+            </a:pPr>
+            <a:r>
+              <a:rPr lang="en-US" sz="1200" b="0">
+                <a:solidFill>
+                  <a:srgbClr val="202b33"/>
+                </a:solidFill>
+                <a:latin typeface="Arial"/>
+                <a:ea typeface="Arial"/>
+                <a:cs typeface="Arial"/>
+              </a:rPr>
+              <a:t xml:space="preserve">Barrel of monkeys: lead with cheap parallel generation, on purpose</a:t>
+            </a:r>
+            <a:endParaRPr lang="en-US" sz="1200"/>
+          </a:p>
+          <a:p>
+            <a:pPr marL="0" indent="0">
+              <a:lnSpc>
+                <a:spcPts val="1560"/>
+              </a:lnSpc>
+              <a:spcAft>
+                <a:spcPts val="0"/>
+              </a:spcAft>
+              <a:buNone/>
+            </a:pPr>
+            <a:r>
+              <a:rPr lang="en-US" sz="1200" b="0">
+                <a:solidFill>
+                  <a:srgbClr val="202b33"/>
+                </a:solidFill>
+                <a:latin typeface="Arial"/>
+                <a:ea typeface="Arial"/>
+                <a:cs typeface="Arial"/>
+              </a:rPr>
+              <a:t xml:space="preserve"/>
+            </a:r>
+            <a:endParaRPr lang="en-US" sz="1200"/>
+          </a:p>
+          <a:p>
+            <a:pPr marL="0" indent="0">
+              <a:lnSpc>
+                <a:spcPts val="1560"/>
+              </a:lnSpc>
+              <a:spcAft>
+                <a:spcPts val="0"/>
+              </a:spcAft>
+              <a:buNone/>
+            </a:pPr>
+            <a:r>
+              <a:rPr lang="en-US" sz="1200" b="0">
+                <a:solidFill>
+                  <a:srgbClr val="202b33"/>
+                </a:solidFill>
+                <a:latin typeface="Arial"/>
+                <a:ea typeface="Arial"/>
+                <a:cs typeface="Arial"/>
+              </a:rPr>
+              <a:t xml:space="preserve">Council of guards: judges read a thousand tokens and write fifty; measure the disagreement</a:t>
             </a:r>
             <a:endParaRPr lang="en-US" sz="1200"/>
           </a:p>
@@ -954,6 +954,98 @@
                 <a:cs typeface="Arial"/>
               </a:rPr>
               <a:t xml:space="preserve">Here is what parallel attempts actually buy. Understanding of the models you depend on: run one brief through two of them and you learn what each reaches for and what each forgets. A migration harness: same brief, new model, diff the behavior before you switch, instead of after the incident. Better output: a synthesis of compatible ideas is often better than any single draft. And the cheap one, which is the one I care about: judging. A judge reads a thousand tokens and writes fifty. Output is what costs, so you can afford three or five judges from different models on every candidate, and the number you want back is not the average score. It is the disagreement. When the judges split or their reasons barely overlap, that candidate is sitting in territory nobody understands, and that is the one you do not ship on autopilot. I call this the Council of Guards. It picks between one and three alternatives to generate, and it costs a fraction of the generation it is guarding.</a:t>
+            </a:r>
+            <a:endParaRPr lang="en-US" sz="1200"/>
+          </a:p>
+          <a:p>
+            <a:pPr marL="0" indent="0">
+              <a:lnSpc>
+                <a:spcPts val="1560"/>
+              </a:lnSpc>
+              <a:spcAft>
+                <a:spcPts val="0"/>
+              </a:spcAft>
+              <a:buNone/>
+            </a:pPr>
+            <a:r>
+              <a:rPr lang="en-US" sz="1200" b="0">
+                <a:solidFill>
+                  <a:srgbClr val="202b33"/>
+                </a:solidFill>
+                <a:latin typeface="Arial"/>
+                <a:ea typeface="Arial"/>
+                <a:cs typeface="Arial"/>
+              </a:rPr>
+              <a:t xml:space="preserve"/>
+            </a:r>
+            <a:endParaRPr lang="en-US" sz="1200"/>
+          </a:p>
+          <a:p>
+            <a:pPr marL="0" indent="0">
+              <a:lnSpc>
+                <a:spcPts val="1560"/>
+              </a:lnSpc>
+              <a:spcAft>
+                <a:spcPts val="0"/>
+              </a:spcAft>
+              <a:buNone/>
+            </a:pPr>
+            <a:r>
+              <a:rPr lang="en-US" sz="1200" b="0">
+                <a:solidFill>
+                  <a:srgbClr val="202b33"/>
+                </a:solidFill>
+                <a:latin typeface="Arial"/>
+                <a:ea typeface="Arial"/>
+                <a:cs typeface="Arial"/>
+              </a:rPr>
+              <a:t xml:space="preserve">The generation side has a name too, and I am not sorry about it: the barrel-of-monkeys maneuver. Lead with parallel generation on purpose. You are adding a controlled section of chaos that the next stage has to handle: a revision loop, a router, the council, or your users in an A/B test. Why you would want the chaos varies. Sometimes you want the fastest answer, so you race. Sometimes you want the best parts of several, so a frontier model, whose input tokens are the cheap ones, reads all of them and writes one coherent output. Sometimes you just want more candidates for the judges to rank so the best whole answer goes downstream. In law or medicine, where the rules are extensive and specific, that is how you catch the one errant mistake that shows up in one output out of ten. And the monkeys can be cheap: models at a hundredth or a thousandth the price of the frontier, generating alternatives in a loop. Some of them need a tool-calling agent with files, search and git, which means a sandbox and somebody's cloud; others single-shot it fine. That is an architecture question about how much effort you want in a system that keeps improving versus one you can retune at runtime. Fan-out is a tool you encapsulate at points in the graph: default model most of the time, n alternatives for a sample of requests. Your needs and your opportunities decide why, where and how often.</a:t>
+            </a:r>
+            <a:endParaRPr lang="en-US" sz="1200"/>
+          </a:p>
+          <a:p>
+            <a:pPr marL="0" indent="0">
+              <a:lnSpc>
+                <a:spcPts val="1560"/>
+              </a:lnSpc>
+              <a:spcAft>
+                <a:spcPts val="0"/>
+              </a:spcAft>
+              <a:buNone/>
+            </a:pPr>
+            <a:r>
+              <a:rPr lang="en-US" sz="1200" b="0">
+                <a:solidFill>
+                  <a:srgbClr val="202b33"/>
+                </a:solidFill>
+                <a:latin typeface="Arial"/>
+                <a:ea typeface="Arial"/>
+                <a:cs typeface="Arial"/>
+              </a:rPr>
+              <a:t xml:space="preserve"/>
+            </a:r>
+            <a:endParaRPr lang="en-US" sz="1200"/>
+          </a:p>
+          <a:p>
+            <a:pPr marL="0" indent="0">
+              <a:lnSpc>
+                <a:spcPts val="1560"/>
+              </a:lnSpc>
+              <a:spcAft>
+                <a:spcPts val="0"/>
+              </a:spcAft>
+              <a:buNone/>
+            </a:pPr>
+            <a:r>
+              <a:rPr lang="en-US" sz="1200" b="0">
+                <a:solidFill>
+                  <a:srgbClr val="202b33"/>
+                </a:solidFill>
+                <a:latin typeface="Arial"/>
+                <a:ea typeface="Arial"/>
+                <a:cs typeface="Arial"/>
+              </a:rPr>
+              <a:t xml:space="preserve">Does this border on speculative optimization dressed up as learning? Yes, possibly. Probably sometimes. We will find out. So do not build any of it without env vars to turn it down, and ideally build the system that adjusts its own fan-out and token burn from what it measures. Right? Right. That system is the companion talk.</a:t>
             </a:r>
             <a:endParaRPr lang="en-US" sz="1200"/>
           </a:p>
@@ -1342,7 +1434,7 @@
                 <a:ea typeface="Arial"/>
                 <a:cs typeface="Arial"/>
               </a:rPr>
-              <a:t xml:space="preserve">Source slide 13. 25:30 to 27:30</a:t>
+              <a:t xml:space="preserve">Source slide 13. 26:00 to 27:30</a:t>
             </a:r>
             <a:endParaRPr lang="en-US" sz="1200"/>
           </a:p>
@@ -4801,7 +4893,7 @@
                 <a:ea typeface="Arial"/>
                 <a:cs typeface="Arial"/>
               </a:rPr>
-              <a:t xml:space="preserve">Source slide 8. 12:30 to 15:30</a:t>
+              <a:t xml:space="preserve">Source slide 8. 12:30 to 15:00</a:t>
             </a:r>
             <a:endParaRPr lang="en-US" sz="1200"/>
           </a:p>
@@ -5374,7 +5466,7 @@
                 <a:ea typeface="Arial"/>
                 <a:cs typeface="Arial"/>
               </a:rPr>
-              <a:t xml:space="preserve">Source slide 10. 15:30 to 18:00</a:t>
+              <a:t xml:space="preserve">Source slide 10. 15:00 to 17:30</a:t>
             </a:r>
             <a:endParaRPr lang="en-US" sz="1200"/>
           </a:p>
@@ -5855,7 +5947,7 @@
                 <a:ea typeface="Arial"/>
                 <a:cs typeface="Arial"/>
               </a:rPr>
-              <a:t xml:space="preserve">Source slide 11. 18:00 to 22:00</a:t>
+              <a:t xml:space="preserve">Source slide 11. 17:30 to 21:30</a:t>
             </a:r>
             <a:endParaRPr lang="en-US" sz="1200"/>
           </a:p>

</xml_diff>